<commit_message>
update L6 and L7
</commit_message>
<xml_diff>
--- a/Seperated/Presentations/L6-Detail-Suni-intellektle-proseslerin-avtomatlasdirilmasi-RPA-AI.pptx
+++ b/Seperated/Presentations/L6-Detail-Suni-intellektle-proseslerin-avtomatlasdirilmasi-RPA-AI.pptx
@@ -361,7 +361,7 @@
             <a:pPr indent="0" algn="r">
               <a:buNone/>
             </a:pPr>
-            <a:fld id="{7EFA4AD5-FE00-49D2-9877-58999C9C9DEE}" type="slidenum">
+            <a:fld id="{774D9624-6B0A-469E-AE23-C9294C2717AF}" type="slidenum">
               <a:rPr b="0" lang="en-US" sz="1400" spc="-1" strike="noStrike">
                 <a:solidFill>
                   <a:srgbClr val="000000"/>
@@ -415,7 +415,7 @@
         <p:spPr>
           <a:xfrm>
             <a:off x="685800" y="1143000"/>
-            <a:ext cx="5485680" cy="3085560"/>
+            <a:ext cx="5485320" cy="3085200"/>
           </a:xfrm>
           <a:prstGeom prst="rect">
             <a:avLst/>
@@ -438,7 +438,7 @@
         <p:spPr>
           <a:xfrm>
             <a:off x="685800" y="4400640"/>
-            <a:ext cx="5485680" cy="3599640"/>
+            <a:ext cx="5485320" cy="3599280"/>
           </a:xfrm>
           <a:prstGeom prst="rect">
             <a:avLst/>
@@ -478,7 +478,7 @@
         <p:spPr>
           <a:xfrm>
             <a:off x="3884760" y="8685360"/>
-            <a:ext cx="2971080" cy="457920"/>
+            <a:ext cx="2970720" cy="457560"/>
           </a:xfrm>
           <a:prstGeom prst="rect">
             <a:avLst/>
@@ -519,7 +519,7 @@
                 <a:tab algn="l" pos="0"/>
               </a:tabLst>
             </a:pPr>
-            <a:fld id="{ADB147B4-1BEA-425E-8EEA-C18772F82B09}" type="slidenum">
+            <a:fld id="{B73DAB3D-0FC1-418F-A9E5-CF6A135199AC}" type="slidenum">
               <a:rPr b="0" lang="en-US" sz="1200" spc="-1" strike="noStrike">
                 <a:solidFill>
                   <a:srgbClr val="000000"/>
@@ -572,7 +572,7 @@
         <p:spPr>
           <a:xfrm>
             <a:off x="685800" y="1143000"/>
-            <a:ext cx="5485680" cy="3085560"/>
+            <a:ext cx="5485320" cy="3085200"/>
           </a:xfrm>
           <a:prstGeom prst="rect">
             <a:avLst/>
@@ -595,7 +595,7 @@
         <p:spPr>
           <a:xfrm>
             <a:off x="685800" y="4400640"/>
-            <a:ext cx="5485680" cy="3599640"/>
+            <a:ext cx="5485320" cy="3599280"/>
           </a:xfrm>
           <a:prstGeom prst="rect">
             <a:avLst/>
@@ -635,7 +635,7 @@
         <p:spPr>
           <a:xfrm>
             <a:off x="3884760" y="8685360"/>
-            <a:ext cx="2971080" cy="457920"/>
+            <a:ext cx="2970720" cy="457560"/>
           </a:xfrm>
           <a:prstGeom prst="rect">
             <a:avLst/>
@@ -676,7 +676,7 @@
                 <a:tab algn="l" pos="0"/>
               </a:tabLst>
             </a:pPr>
-            <a:fld id="{4CD146D2-76A3-4AD9-934B-5D81F82A30E0}" type="slidenum">
+            <a:fld id="{80BF482A-F407-4790-99F2-CD64D0218C0B}" type="slidenum">
               <a:rPr b="0" lang="en-US" sz="1200" spc="-1" strike="noStrike">
                 <a:solidFill>
                   <a:srgbClr val="000000"/>
@@ -729,7 +729,7 @@
         <p:spPr>
           <a:xfrm>
             <a:off x="685800" y="1143000"/>
-            <a:ext cx="5485680" cy="3085560"/>
+            <a:ext cx="5485320" cy="3085200"/>
           </a:xfrm>
           <a:prstGeom prst="rect">
             <a:avLst/>
@@ -752,7 +752,7 @@
         <p:spPr>
           <a:xfrm>
             <a:off x="685800" y="4400640"/>
-            <a:ext cx="5485680" cy="3599640"/>
+            <a:ext cx="5485320" cy="3599280"/>
           </a:xfrm>
           <a:prstGeom prst="rect">
             <a:avLst/>
@@ -792,7 +792,7 @@
         <p:spPr>
           <a:xfrm>
             <a:off x="3884760" y="8685360"/>
-            <a:ext cx="2971080" cy="457920"/>
+            <a:ext cx="2970720" cy="457560"/>
           </a:xfrm>
           <a:prstGeom prst="rect">
             <a:avLst/>
@@ -833,7 +833,7 @@
                 <a:tab algn="l" pos="0"/>
               </a:tabLst>
             </a:pPr>
-            <a:fld id="{C34C7B50-DDB1-4C11-9537-DE72BFC2B3ED}" type="slidenum">
+            <a:fld id="{9923325A-E904-4295-A9FB-133AC4DEABBE}" type="slidenum">
               <a:rPr b="0" lang="en-US" sz="1200" spc="-1" strike="noStrike">
                 <a:solidFill>
                   <a:srgbClr val="000000"/>
@@ -886,7 +886,7 @@
         <p:spPr>
           <a:xfrm>
             <a:off x="685800" y="1143000"/>
-            <a:ext cx="5485680" cy="3085560"/>
+            <a:ext cx="5485320" cy="3085200"/>
           </a:xfrm>
           <a:prstGeom prst="rect">
             <a:avLst/>
@@ -909,7 +909,7 @@
         <p:spPr>
           <a:xfrm>
             <a:off x="685800" y="4400640"/>
-            <a:ext cx="5485680" cy="3599640"/>
+            <a:ext cx="5485320" cy="3599280"/>
           </a:xfrm>
           <a:prstGeom prst="rect">
             <a:avLst/>
@@ -949,7 +949,7 @@
         <p:spPr>
           <a:xfrm>
             <a:off x="3884760" y="8685360"/>
-            <a:ext cx="2971080" cy="457920"/>
+            <a:ext cx="2970720" cy="457560"/>
           </a:xfrm>
           <a:prstGeom prst="rect">
             <a:avLst/>
@@ -990,7 +990,7 @@
                 <a:tab algn="l" pos="0"/>
               </a:tabLst>
             </a:pPr>
-            <a:fld id="{6A3A89CB-024E-43DE-95E4-C3992F9814D8}" type="slidenum">
+            <a:fld id="{A73FA3CD-2577-4872-90A4-74265662DEDF}" type="slidenum">
               <a:rPr b="0" lang="en-US" sz="1200" spc="-1" strike="noStrike">
                 <a:solidFill>
                   <a:srgbClr val="000000"/>
@@ -1043,7 +1043,7 @@
         <p:spPr>
           <a:xfrm>
             <a:off x="685800" y="1143000"/>
-            <a:ext cx="5485680" cy="3085560"/>
+            <a:ext cx="5485320" cy="3085200"/>
           </a:xfrm>
           <a:prstGeom prst="rect">
             <a:avLst/>
@@ -1066,7 +1066,7 @@
         <p:spPr>
           <a:xfrm>
             <a:off x="685800" y="4400640"/>
-            <a:ext cx="5485680" cy="3599640"/>
+            <a:ext cx="5485320" cy="3599280"/>
           </a:xfrm>
           <a:prstGeom prst="rect">
             <a:avLst/>
@@ -1106,7 +1106,7 @@
         <p:spPr>
           <a:xfrm>
             <a:off x="3884760" y="8685360"/>
-            <a:ext cx="2971080" cy="457920"/>
+            <a:ext cx="2970720" cy="457560"/>
           </a:xfrm>
           <a:prstGeom prst="rect">
             <a:avLst/>
@@ -1147,7 +1147,7 @@
                 <a:tab algn="l" pos="0"/>
               </a:tabLst>
             </a:pPr>
-            <a:fld id="{36471B94-E6B1-4682-A704-2AD0826C67ED}" type="slidenum">
+            <a:fld id="{724920DE-3603-4EC2-9D7C-BE4F3D3073B8}" type="slidenum">
               <a:rPr b="0" lang="en-US" sz="1200" spc="-1" strike="noStrike">
                 <a:solidFill>
                   <a:srgbClr val="000000"/>
@@ -1200,7 +1200,7 @@
         <p:spPr>
           <a:xfrm>
             <a:off x="685800" y="1143000"/>
-            <a:ext cx="5485680" cy="3085560"/>
+            <a:ext cx="5485320" cy="3085200"/>
           </a:xfrm>
           <a:prstGeom prst="rect">
             <a:avLst/>
@@ -1223,7 +1223,7 @@
         <p:spPr>
           <a:xfrm>
             <a:off x="685800" y="4400640"/>
-            <a:ext cx="5485680" cy="3599640"/>
+            <a:ext cx="5485320" cy="3599280"/>
           </a:xfrm>
           <a:prstGeom prst="rect">
             <a:avLst/>
@@ -1263,7 +1263,7 @@
         <p:spPr>
           <a:xfrm>
             <a:off x="3884760" y="8685360"/>
-            <a:ext cx="2971080" cy="457920"/>
+            <a:ext cx="2970720" cy="457560"/>
           </a:xfrm>
           <a:prstGeom prst="rect">
             <a:avLst/>
@@ -1304,7 +1304,7 @@
                 <a:tab algn="l" pos="0"/>
               </a:tabLst>
             </a:pPr>
-            <a:fld id="{8B50B0DD-BA6D-498B-830D-FDEB75F2EAE2}" type="slidenum">
+            <a:fld id="{FF36C6E8-ADE2-48DF-9E32-27A7EF3C765F}" type="slidenum">
               <a:rPr b="0" lang="en-US" sz="1200" spc="-1" strike="noStrike">
                 <a:solidFill>
                   <a:srgbClr val="000000"/>
@@ -1357,7 +1357,7 @@
         <p:spPr>
           <a:xfrm>
             <a:off x="685800" y="1143000"/>
-            <a:ext cx="5485680" cy="3085560"/>
+            <a:ext cx="5485320" cy="3085200"/>
           </a:xfrm>
           <a:prstGeom prst="rect">
             <a:avLst/>
@@ -1380,7 +1380,7 @@
         <p:spPr>
           <a:xfrm>
             <a:off x="685800" y="4400640"/>
-            <a:ext cx="5485680" cy="3599640"/>
+            <a:ext cx="5485320" cy="3599280"/>
           </a:xfrm>
           <a:prstGeom prst="rect">
             <a:avLst/>
@@ -1420,7 +1420,7 @@
         <p:spPr>
           <a:xfrm>
             <a:off x="3884760" y="8685360"/>
-            <a:ext cx="2971080" cy="457920"/>
+            <a:ext cx="2970720" cy="457560"/>
           </a:xfrm>
           <a:prstGeom prst="rect">
             <a:avLst/>
@@ -1461,7 +1461,7 @@
                 <a:tab algn="l" pos="0"/>
               </a:tabLst>
             </a:pPr>
-            <a:fld id="{D481B310-2083-4BF7-9412-AF39E0E97B3F}" type="slidenum">
+            <a:fld id="{C140C5B6-902A-4DDF-B032-02339ADFF5E5}" type="slidenum">
               <a:rPr b="0" lang="en-US" sz="1200" spc="-1" strike="noStrike">
                 <a:solidFill>
                   <a:srgbClr val="000000"/>
@@ -1514,7 +1514,7 @@
         <p:spPr>
           <a:xfrm>
             <a:off x="685800" y="1143000"/>
-            <a:ext cx="5485680" cy="3085560"/>
+            <a:ext cx="5485320" cy="3085200"/>
           </a:xfrm>
           <a:prstGeom prst="rect">
             <a:avLst/>
@@ -1537,7 +1537,7 @@
         <p:spPr>
           <a:xfrm>
             <a:off x="685800" y="4400640"/>
-            <a:ext cx="5485680" cy="3599640"/>
+            <a:ext cx="5485320" cy="3599280"/>
           </a:xfrm>
           <a:prstGeom prst="rect">
             <a:avLst/>
@@ -1577,7 +1577,7 @@
         <p:spPr>
           <a:xfrm>
             <a:off x="3884760" y="8685360"/>
-            <a:ext cx="2971080" cy="457920"/>
+            <a:ext cx="2970720" cy="457560"/>
           </a:xfrm>
           <a:prstGeom prst="rect">
             <a:avLst/>
@@ -1618,7 +1618,7 @@
                 <a:tab algn="l" pos="0"/>
               </a:tabLst>
             </a:pPr>
-            <a:fld id="{5E180952-B40C-4D74-BF9A-56534FAF2335}" type="slidenum">
+            <a:fld id="{CC700C32-6A8D-451A-8999-95AF19E4C74A}" type="slidenum">
               <a:rPr b="0" lang="en-US" sz="1200" spc="-1" strike="noStrike">
                 <a:solidFill>
                   <a:srgbClr val="000000"/>
@@ -1671,7 +1671,7 @@
         <p:spPr>
           <a:xfrm>
             <a:off x="685800" y="1143000"/>
-            <a:ext cx="5485680" cy="3085560"/>
+            <a:ext cx="5485320" cy="3085200"/>
           </a:xfrm>
           <a:prstGeom prst="rect">
             <a:avLst/>
@@ -1694,7 +1694,7 @@
         <p:spPr>
           <a:xfrm>
             <a:off x="685800" y="4400640"/>
-            <a:ext cx="5485680" cy="3599640"/>
+            <a:ext cx="5485320" cy="3599280"/>
           </a:xfrm>
           <a:prstGeom prst="rect">
             <a:avLst/>
@@ -1734,7 +1734,7 @@
         <p:spPr>
           <a:xfrm>
             <a:off x="3884760" y="8685360"/>
-            <a:ext cx="2971080" cy="457920"/>
+            <a:ext cx="2970720" cy="457560"/>
           </a:xfrm>
           <a:prstGeom prst="rect">
             <a:avLst/>
@@ -1775,7 +1775,7 @@
                 <a:tab algn="l" pos="0"/>
               </a:tabLst>
             </a:pPr>
-            <a:fld id="{7B476EED-2F15-49E4-8499-EFE46402D588}" type="slidenum">
+            <a:fld id="{1F0439BA-F834-4593-89EE-630B537D0D38}" type="slidenum">
               <a:rPr b="0" lang="en-US" sz="1200" spc="-1" strike="noStrike">
                 <a:solidFill>
                   <a:srgbClr val="000000"/>
@@ -1828,7 +1828,7 @@
         <p:spPr>
           <a:xfrm>
             <a:off x="685800" y="1143000"/>
-            <a:ext cx="5485680" cy="3085560"/>
+            <a:ext cx="5485320" cy="3085200"/>
           </a:xfrm>
           <a:prstGeom prst="rect">
             <a:avLst/>
@@ -1851,7 +1851,7 @@
         <p:spPr>
           <a:xfrm>
             <a:off x="685800" y="4400640"/>
-            <a:ext cx="5485680" cy="3599640"/>
+            <a:ext cx="5485320" cy="3599280"/>
           </a:xfrm>
           <a:prstGeom prst="rect">
             <a:avLst/>
@@ -1891,7 +1891,7 @@
         <p:spPr>
           <a:xfrm>
             <a:off x="3884760" y="8685360"/>
-            <a:ext cx="2971080" cy="457920"/>
+            <a:ext cx="2970720" cy="457560"/>
           </a:xfrm>
           <a:prstGeom prst="rect">
             <a:avLst/>
@@ -1932,7 +1932,7 @@
                 <a:tab algn="l" pos="0"/>
               </a:tabLst>
             </a:pPr>
-            <a:fld id="{E9D82FE9-00E1-4703-A6D1-E76E04D46C52}" type="slidenum">
+            <a:fld id="{1B86351B-F007-4B25-B6AC-2653676E03CC}" type="slidenum">
               <a:rPr b="0" lang="en-US" sz="1200" spc="-1" strike="noStrike">
                 <a:solidFill>
                   <a:srgbClr val="000000"/>
@@ -1985,7 +1985,7 @@
         <p:spPr>
           <a:xfrm>
             <a:off x="685800" y="1143000"/>
-            <a:ext cx="5485680" cy="3085560"/>
+            <a:ext cx="5485320" cy="3085200"/>
           </a:xfrm>
           <a:prstGeom prst="rect">
             <a:avLst/>
@@ -2008,7 +2008,7 @@
         <p:spPr>
           <a:xfrm>
             <a:off x="685800" y="4400640"/>
-            <a:ext cx="5485680" cy="3599640"/>
+            <a:ext cx="5485320" cy="3599280"/>
           </a:xfrm>
           <a:prstGeom prst="rect">
             <a:avLst/>
@@ -2048,7 +2048,7 @@
         <p:spPr>
           <a:xfrm>
             <a:off x="3884760" y="8685360"/>
-            <a:ext cx="2971080" cy="457920"/>
+            <a:ext cx="2970720" cy="457560"/>
           </a:xfrm>
           <a:prstGeom prst="rect">
             <a:avLst/>
@@ -2089,7 +2089,7 @@
                 <a:tab algn="l" pos="0"/>
               </a:tabLst>
             </a:pPr>
-            <a:fld id="{3C799DE9-2051-4CF4-BCFF-A160DAFD3DB7}" type="slidenum">
+            <a:fld id="{92F3F217-7B5C-468E-B1CE-C47D667F0235}" type="slidenum">
               <a:rPr b="0" lang="en-US" sz="1200" spc="-1" strike="noStrike">
                 <a:solidFill>
                   <a:srgbClr val="000000"/>
@@ -2435,7 +2435,7 @@
         <p:spPr>
           <a:xfrm>
             <a:off x="0" y="0"/>
-            <a:ext cx="14629680" cy="8228880"/>
+            <a:ext cx="14629320" cy="8228520"/>
           </a:xfrm>
           <a:prstGeom prst="rect">
             <a:avLst/>
@@ -2481,7 +2481,7 @@
         <p:spPr>
           <a:xfrm>
             <a:off x="0" y="0"/>
-            <a:ext cx="14629680" cy="8228880"/>
+            <a:ext cx="14629320" cy="8228520"/>
           </a:xfrm>
           <a:prstGeom prst="rect">
             <a:avLst/>
@@ -2827,7 +2827,7 @@
         <p:spPr>
           <a:xfrm>
             <a:off x="0" y="0"/>
-            <a:ext cx="14629680" cy="8228880"/>
+            <a:ext cx="14629320" cy="8228520"/>
           </a:xfrm>
           <a:prstGeom prst="rect">
             <a:avLst/>
@@ -2873,7 +2873,7 @@
         <p:spPr>
           <a:xfrm>
             <a:off x="0" y="0"/>
-            <a:ext cx="14629680" cy="8228880"/>
+            <a:ext cx="14629320" cy="8228520"/>
           </a:xfrm>
           <a:prstGeom prst="rect">
             <a:avLst/>
@@ -3219,7 +3219,7 @@
         <p:spPr>
           <a:xfrm>
             <a:off x="0" y="0"/>
-            <a:ext cx="14629680" cy="8228880"/>
+            <a:ext cx="14629320" cy="8228520"/>
           </a:xfrm>
           <a:prstGeom prst="rect">
             <a:avLst/>
@@ -3265,7 +3265,7 @@
         <p:spPr>
           <a:xfrm>
             <a:off x="0" y="0"/>
-            <a:ext cx="14629680" cy="8228880"/>
+            <a:ext cx="14629320" cy="8228520"/>
           </a:xfrm>
           <a:prstGeom prst="rect">
             <a:avLst/>
@@ -3611,7 +3611,7 @@
         <p:spPr>
           <a:xfrm>
             <a:off x="0" y="0"/>
-            <a:ext cx="14629680" cy="8228880"/>
+            <a:ext cx="14629320" cy="8228520"/>
           </a:xfrm>
           <a:prstGeom prst="rect">
             <a:avLst/>
@@ -3657,7 +3657,7 @@
         <p:spPr>
           <a:xfrm>
             <a:off x="0" y="0"/>
-            <a:ext cx="14629680" cy="8228880"/>
+            <a:ext cx="14629320" cy="8228520"/>
           </a:xfrm>
           <a:prstGeom prst="rect">
             <a:avLst/>
@@ -3732,25 +3732,7 @@
                 </a:solidFill>
                 <a:latin typeface="Arial"/>
               </a:rPr>
-              <a:t>Click to edit </a:t>
-            </a:r>
-            <a:r>
-              <a:rPr b="0" lang="en-US" sz="4400" spc="-1" strike="noStrike">
-                <a:solidFill>
-                  <a:srgbClr val="000000"/>
-                </a:solidFill>
-                <a:latin typeface="Arial"/>
-              </a:rPr>
-              <a:t>the title text </a:t>
-            </a:r>
-            <a:r>
-              <a:rPr b="0" lang="en-US" sz="4400" spc="-1" strike="noStrike">
-                <a:solidFill>
-                  <a:srgbClr val="000000"/>
-                </a:solidFill>
-                <a:latin typeface="Arial"/>
-              </a:rPr>
-              <a:t>format</a:t>
+              <a:t>Click to edit the title text format</a:t>
             </a:r>
             <a:endParaRPr b="0" lang="en-US" sz="4400" spc="-1" strike="noStrike">
               <a:solidFill>
@@ -4021,7 +4003,7 @@
         <p:spPr>
           <a:xfrm>
             <a:off x="0" y="0"/>
-            <a:ext cx="14629680" cy="8228880"/>
+            <a:ext cx="14629320" cy="8228520"/>
           </a:xfrm>
           <a:prstGeom prst="rect">
             <a:avLst/>
@@ -4067,7 +4049,7 @@
         <p:spPr>
           <a:xfrm>
             <a:off x="0" y="0"/>
-            <a:ext cx="14629680" cy="8228880"/>
+            <a:ext cx="14629320" cy="8228520"/>
           </a:xfrm>
           <a:prstGeom prst="rect">
             <a:avLst/>
@@ -4142,16 +4124,7 @@
                 </a:solidFill>
                 <a:latin typeface="Arial"/>
               </a:rPr>
-              <a:t>Click to edit the </a:t>
-            </a:r>
-            <a:r>
-              <a:rPr b="0" lang="en-US" sz="4400" spc="-1" strike="noStrike">
-                <a:solidFill>
-                  <a:srgbClr val="000000"/>
-                </a:solidFill>
-                <a:latin typeface="Arial"/>
-              </a:rPr>
-              <a:t>title text format</a:t>
+              <a:t>Click to edit the title text format</a:t>
             </a:r>
             <a:endParaRPr b="0" lang="en-US" sz="4400" spc="-1" strike="noStrike">
               <a:solidFill>
@@ -4422,7 +4395,7 @@
         <p:spPr>
           <a:xfrm>
             <a:off x="0" y="0"/>
-            <a:ext cx="14629680" cy="8228880"/>
+            <a:ext cx="14629320" cy="8228520"/>
           </a:xfrm>
           <a:prstGeom prst="rect">
             <a:avLst/>
@@ -4468,7 +4441,7 @@
         <p:spPr>
           <a:xfrm>
             <a:off x="0" y="0"/>
-            <a:ext cx="14629680" cy="8228880"/>
+            <a:ext cx="14629320" cy="8228520"/>
           </a:xfrm>
           <a:prstGeom prst="rect">
             <a:avLst/>
@@ -4543,25 +4516,7 @@
                 </a:solidFill>
                 <a:latin typeface="Arial"/>
               </a:rPr>
-              <a:t>Click to edit </a:t>
-            </a:r>
-            <a:r>
-              <a:rPr b="0" lang="en-US" sz="4400" spc="-1" strike="noStrike">
-                <a:solidFill>
-                  <a:srgbClr val="000000"/>
-                </a:solidFill>
-                <a:latin typeface="Arial"/>
-              </a:rPr>
-              <a:t>the title text </a:t>
-            </a:r>
-            <a:r>
-              <a:rPr b="0" lang="en-US" sz="4400" spc="-1" strike="noStrike">
-                <a:solidFill>
-                  <a:srgbClr val="000000"/>
-                </a:solidFill>
-                <a:latin typeface="Arial"/>
-              </a:rPr>
-              <a:t>format</a:t>
+              <a:t>Click to edit the title text format</a:t>
             </a:r>
             <a:endParaRPr b="0" lang="en-US" sz="4400" spc="-1" strike="noStrike">
               <a:solidFill>
@@ -4832,7 +4787,7 @@
         <p:spPr>
           <a:xfrm>
             <a:off x="0" y="0"/>
-            <a:ext cx="14629680" cy="8228880"/>
+            <a:ext cx="14629320" cy="8228520"/>
           </a:xfrm>
           <a:prstGeom prst="rect">
             <a:avLst/>
@@ -4878,7 +4833,7 @@
         <p:spPr>
           <a:xfrm>
             <a:off x="0" y="0"/>
-            <a:ext cx="14629680" cy="8228880"/>
+            <a:ext cx="14629320" cy="8228520"/>
           </a:xfrm>
           <a:prstGeom prst="rect">
             <a:avLst/>
@@ -4953,16 +4908,7 @@
                 </a:solidFill>
                 <a:latin typeface="Arial"/>
               </a:rPr>
-              <a:t>Click to edit the </a:t>
-            </a:r>
-            <a:r>
-              <a:rPr b="0" lang="en-US" sz="4400" spc="-1" strike="noStrike">
-                <a:solidFill>
-                  <a:srgbClr val="000000"/>
-                </a:solidFill>
-                <a:latin typeface="Arial"/>
-              </a:rPr>
-              <a:t>title text format</a:t>
+              <a:t>Click to edit the title text format</a:t>
             </a:r>
             <a:endParaRPr b="0" lang="en-US" sz="4400" spc="-1" strike="noStrike">
               <a:solidFill>
@@ -5233,7 +5179,7 @@
         <p:spPr>
           <a:xfrm>
             <a:off x="0" y="0"/>
-            <a:ext cx="14629680" cy="8228880"/>
+            <a:ext cx="14629320" cy="8228520"/>
           </a:xfrm>
           <a:prstGeom prst="rect">
             <a:avLst/>
@@ -5279,7 +5225,7 @@
         <p:spPr>
           <a:xfrm>
             <a:off x="0" y="0"/>
-            <a:ext cx="14629680" cy="8228880"/>
+            <a:ext cx="14629320" cy="8228520"/>
           </a:xfrm>
           <a:prstGeom prst="rect">
             <a:avLst/>
@@ -5354,34 +5300,7 @@
                 </a:solidFill>
                 <a:latin typeface="Arial"/>
               </a:rPr>
-              <a:t>Click to </a:t>
-            </a:r>
-            <a:r>
-              <a:rPr b="0" lang="en-US" sz="4400" spc="-1" strike="noStrike">
-                <a:solidFill>
-                  <a:srgbClr val="000000"/>
-                </a:solidFill>
-                <a:latin typeface="Arial"/>
-              </a:rPr>
-              <a:t>edit the </a:t>
-            </a:r>
-            <a:r>
-              <a:rPr b="0" lang="en-US" sz="4400" spc="-1" strike="noStrike">
-                <a:solidFill>
-                  <a:srgbClr val="000000"/>
-                </a:solidFill>
-                <a:latin typeface="Arial"/>
-              </a:rPr>
-              <a:t>title text </a:t>
-            </a:r>
-            <a:r>
-              <a:rPr b="0" lang="en-US" sz="4400" spc="-1" strike="noStrike">
-                <a:solidFill>
-                  <a:srgbClr val="000000"/>
-                </a:solidFill>
-                <a:latin typeface="Arial"/>
-              </a:rPr>
-              <a:t>format</a:t>
+              <a:t>Click to edit the title text format</a:t>
             </a:r>
             <a:endParaRPr b="0" lang="en-US" sz="4400" spc="-1" strike="noStrike">
               <a:solidFill>
@@ -5652,7 +5571,7 @@
         <p:spPr>
           <a:xfrm>
             <a:off x="0" y="0"/>
-            <a:ext cx="14629680" cy="8228880"/>
+            <a:ext cx="14629320" cy="8228520"/>
           </a:xfrm>
           <a:prstGeom prst="rect">
             <a:avLst/>
@@ -5698,7 +5617,7 @@
         <p:spPr>
           <a:xfrm>
             <a:off x="0" y="0"/>
-            <a:ext cx="14629680" cy="8228880"/>
+            <a:ext cx="14629320" cy="8228520"/>
           </a:xfrm>
           <a:prstGeom prst="rect">
             <a:avLst/>
@@ -6044,7 +5963,7 @@
         <p:spPr>
           <a:xfrm>
             <a:off x="0" y="0"/>
-            <a:ext cx="14629680" cy="8228880"/>
+            <a:ext cx="14629320" cy="8228520"/>
           </a:xfrm>
           <a:prstGeom prst="rect">
             <a:avLst/>
@@ -6090,7 +6009,7 @@
         <p:spPr>
           <a:xfrm>
             <a:off x="0" y="0"/>
-            <a:ext cx="14629680" cy="8228880"/>
+            <a:ext cx="14629320" cy="8228520"/>
           </a:xfrm>
           <a:prstGeom prst="rect">
             <a:avLst/>
@@ -6436,7 +6355,7 @@
         <p:spPr>
           <a:xfrm>
             <a:off x="0" y="0"/>
-            <a:ext cx="14629680" cy="8228880"/>
+            <a:ext cx="14629320" cy="8228520"/>
           </a:xfrm>
           <a:prstGeom prst="rect">
             <a:avLst/>
@@ -6482,7 +6401,7 @@
         <p:spPr>
           <a:xfrm>
             <a:off x="0" y="0"/>
-            <a:ext cx="14629680" cy="8228880"/>
+            <a:ext cx="14629320" cy="8228520"/>
           </a:xfrm>
           <a:prstGeom prst="rect">
             <a:avLst/>
@@ -6557,16 +6476,7 @@
                 </a:solidFill>
                 <a:latin typeface="Arial"/>
               </a:rPr>
-              <a:t>Click to edit the </a:t>
-            </a:r>
-            <a:r>
-              <a:rPr b="0" lang="en-US" sz="4400" spc="-1" strike="noStrike">
-                <a:solidFill>
-                  <a:srgbClr val="000000"/>
-                </a:solidFill>
-                <a:latin typeface="Arial"/>
-              </a:rPr>
-              <a:t>title text format</a:t>
+              <a:t>Click to edit the title text format</a:t>
             </a:r>
             <a:endParaRPr b="0" lang="en-US" sz="4400" spc="-1" strike="noStrike">
               <a:solidFill>
@@ -6841,7 +6751,7 @@
         <p:spPr>
           <a:xfrm>
             <a:off x="0" y="0"/>
-            <a:ext cx="5485680" cy="8228880"/>
+            <a:ext cx="5485320" cy="8228520"/>
           </a:xfrm>
           <a:prstGeom prst="rect">
             <a:avLst/>
@@ -6860,7 +6770,7 @@
         <p:spPr>
           <a:xfrm>
             <a:off x="6350040" y="2223360"/>
-            <a:ext cx="7415640" cy="1839960"/>
+            <a:ext cx="7415280" cy="1839600"/>
           </a:xfrm>
           <a:prstGeom prst="rect">
             <a:avLst/>
@@ -6917,7 +6827,7 @@
         <p:spPr>
           <a:xfrm>
             <a:off x="6350040" y="4387680"/>
-            <a:ext cx="7415640" cy="971280"/>
+            <a:ext cx="7415280" cy="970920"/>
           </a:xfrm>
           <a:prstGeom prst="rect">
             <a:avLst/>
@@ -6974,7 +6884,7 @@
         <p:spPr>
           <a:xfrm>
             <a:off x="6458040" y="5602320"/>
-            <a:ext cx="1992960" cy="403200"/>
+            <a:ext cx="1992600" cy="402840"/>
           </a:xfrm>
           <a:prstGeom prst="roundRect">
             <a:avLst>
@@ -7023,7 +6933,7 @@
         <p:spPr>
           <a:xfrm>
             <a:off x="6487200" y="5675040"/>
-            <a:ext cx="1718640" cy="258480"/>
+            <a:ext cx="1718280" cy="258120"/>
           </a:xfrm>
           <a:prstGeom prst="rect">
             <a:avLst/>
@@ -7114,7 +7024,7 @@
         <p:spPr>
           <a:xfrm>
             <a:off x="0" y="0"/>
-            <a:ext cx="5485680" cy="8228880"/>
+            <a:ext cx="5485320" cy="8228520"/>
           </a:xfrm>
           <a:prstGeom prst="rect">
             <a:avLst/>
@@ -7133,7 +7043,7 @@
         <p:spPr>
           <a:xfrm>
             <a:off x="6341400" y="594000"/>
-            <a:ext cx="6566400" cy="606600"/>
+            <a:ext cx="6566040" cy="606240"/>
           </a:xfrm>
           <a:prstGeom prst="rect">
             <a:avLst/>
@@ -7190,7 +7100,7 @@
         <p:spPr>
           <a:xfrm>
             <a:off x="6341400" y="1230840"/>
-            <a:ext cx="7432920" cy="956520"/>
+            <a:ext cx="7432560" cy="956160"/>
           </a:xfrm>
           <a:prstGeom prst="rect">
             <a:avLst/>
@@ -7247,7 +7157,7 @@
         <p:spPr>
           <a:xfrm>
             <a:off x="6341400" y="2714040"/>
-            <a:ext cx="3610440" cy="3144240"/>
+            <a:ext cx="3610080" cy="3143880"/>
           </a:xfrm>
           <a:prstGeom prst="roundRect">
             <a:avLst>
@@ -7298,7 +7208,7 @@
         <p:spPr>
           <a:xfrm>
             <a:off x="6585840" y="2958480"/>
-            <a:ext cx="2675520" cy="310680"/>
+            <a:ext cx="2675160" cy="310320"/>
           </a:xfrm>
           <a:prstGeom prst="rect">
             <a:avLst/>
@@ -7375,7 +7285,7 @@
         <p:spPr>
           <a:xfrm>
             <a:off x="6585840" y="3396600"/>
-            <a:ext cx="3121920" cy="1594800"/>
+            <a:ext cx="3121560" cy="1594440"/>
           </a:xfrm>
           <a:prstGeom prst="rect">
             <a:avLst/>
@@ -7412,7 +7322,7 @@
                 <a:latin typeface="Source Sans 3"/>
                 <a:ea typeface="Source Sans 3"/>
               </a:rPr>
-              <a:t>Əməkdaşların ən böyük narahatlığı budur. Açıq ünsiyyət, şəffaflıq və "botlar işlərimi əlimdən alır" deyil, "botlar məni azad edir" mesajı vacibdir.</a:t>
+              <a:t>Əməkdaşların ən böyük narahatlığı budur. Açıq ünsiyyət, şəffaflıq və "botlar işimi ələ keçirir" əvəzinə "botlar məni azad edir" anlayışı ən vacib məsələlərdir.</a:t>
             </a:r>
             <a:endParaRPr b="0" lang="en-US" sz="1650" spc="-1" strike="noStrike">
               <a:solidFill>
@@ -7432,7 +7342,7 @@
         <p:spPr>
           <a:xfrm>
             <a:off x="10164240" y="2714040"/>
-            <a:ext cx="3610440" cy="3144240"/>
+            <a:ext cx="3610080" cy="3143880"/>
           </a:xfrm>
           <a:prstGeom prst="roundRect">
             <a:avLst>
@@ -7482,8 +7392,8 @@
         </p:nvSpPr>
         <p:spPr>
           <a:xfrm>
-            <a:off x="10408320" y="2958480"/>
-            <a:ext cx="3121920" cy="614520"/>
+            <a:off x="10408320" y="2814480"/>
+            <a:ext cx="3121560" cy="614160"/>
           </a:xfrm>
           <a:prstGeom prst="rect">
             <a:avLst/>
@@ -7559,8 +7469,8 @@
         </p:nvSpPr>
         <p:spPr>
           <a:xfrm>
-            <a:off x="10408320" y="3700440"/>
-            <a:ext cx="3121920" cy="1913760"/>
+            <a:off x="10408320" y="3448440"/>
+            <a:ext cx="3121560" cy="1913400"/>
           </a:xfrm>
           <a:prstGeom prst="rect">
             <a:avLst/>
@@ -7617,7 +7527,7 @@
         <p:spPr>
           <a:xfrm>
             <a:off x="6341400" y="6070680"/>
-            <a:ext cx="7432920" cy="1564200"/>
+            <a:ext cx="7432560" cy="1563840"/>
           </a:xfrm>
           <a:prstGeom prst="roundRect">
             <a:avLst>
@@ -7668,7 +7578,7 @@
         <p:spPr>
           <a:xfrm>
             <a:off x="6585840" y="6314760"/>
-            <a:ext cx="2928600" cy="310680"/>
+            <a:ext cx="2928240" cy="310320"/>
           </a:xfrm>
           <a:prstGeom prst="rect">
             <a:avLst/>
@@ -7745,7 +7655,7 @@
         <p:spPr>
           <a:xfrm>
             <a:off x="6585840" y="6753240"/>
-            <a:ext cx="6944760" cy="637560"/>
+            <a:ext cx="6944400" cy="637200"/>
           </a:xfrm>
           <a:prstGeom prst="rect">
             <a:avLst/>
@@ -7832,7 +7742,7 @@
         <p:spPr>
           <a:xfrm>
             <a:off x="820440" y="804600"/>
-            <a:ext cx="4661640" cy="582120"/>
+            <a:ext cx="4661280" cy="581760"/>
           </a:xfrm>
           <a:prstGeom prst="rect">
             <a:avLst/>
@@ -7889,7 +7799,7 @@
         <p:spPr>
           <a:xfrm>
             <a:off x="820440" y="1776960"/>
-            <a:ext cx="12988440" cy="299160"/>
+            <a:ext cx="12988080" cy="298800"/>
           </a:xfrm>
           <a:prstGeom prst="rect">
             <a:avLst/>
@@ -7946,7 +7856,7 @@
         <p:spPr>
           <a:xfrm>
             <a:off x="1128240" y="2515320"/>
-            <a:ext cx="12681000" cy="599040"/>
+            <a:ext cx="12680640" cy="598680"/>
           </a:xfrm>
           <a:prstGeom prst="rect">
             <a:avLst/>
@@ -8023,7 +7933,7 @@
         <p:spPr>
           <a:xfrm>
             <a:off x="820440" y="2296080"/>
-            <a:ext cx="22320" cy="1037520"/>
+            <a:ext cx="21960" cy="1037160"/>
           </a:xfrm>
           <a:prstGeom prst="rect">
             <a:avLst/>
@@ -8073,7 +7983,7 @@
         <p:spPr>
           <a:xfrm>
             <a:off x="820440" y="3553560"/>
-            <a:ext cx="4329000" cy="819720"/>
+            <a:ext cx="4328640" cy="819360"/>
           </a:xfrm>
           <a:prstGeom prst="rect">
             <a:avLst/>
@@ -8092,7 +8002,7 @@
         <p:spPr>
           <a:xfrm>
             <a:off x="1025640" y="4568760"/>
-            <a:ext cx="2749680" cy="290520"/>
+            <a:ext cx="2749320" cy="290160"/>
           </a:xfrm>
           <a:prstGeom prst="rect">
             <a:avLst/>
@@ -8149,7 +8059,7 @@
         <p:spPr>
           <a:xfrm>
             <a:off x="1025640" y="4977000"/>
-            <a:ext cx="3918600" cy="898920"/>
+            <a:ext cx="3918240" cy="898560"/>
           </a:xfrm>
           <a:prstGeom prst="rect">
             <a:avLst/>
@@ -8210,7 +8120,7 @@
         <p:spPr>
           <a:xfrm>
             <a:off x="5150160" y="3553560"/>
-            <a:ext cx="4329000" cy="819720"/>
+            <a:ext cx="4328640" cy="819360"/>
           </a:xfrm>
           <a:prstGeom prst="rect">
             <a:avLst/>
@@ -8229,7 +8139,7 @@
         <p:spPr>
           <a:xfrm>
             <a:off x="5355360" y="4568760"/>
-            <a:ext cx="3082320" cy="290520"/>
+            <a:ext cx="3081960" cy="290160"/>
           </a:xfrm>
           <a:prstGeom prst="rect">
             <a:avLst/>
@@ -8286,7 +8196,7 @@
         <p:spPr>
           <a:xfrm>
             <a:off x="5355360" y="4977000"/>
-            <a:ext cx="3918600" cy="1198800"/>
+            <a:ext cx="3918240" cy="1198440"/>
           </a:xfrm>
           <a:prstGeom prst="rect">
             <a:avLst/>
@@ -8347,7 +8257,7 @@
         <p:spPr>
           <a:xfrm>
             <a:off x="9479880" y="3553560"/>
-            <a:ext cx="4329000" cy="819720"/>
+            <a:ext cx="4328640" cy="819360"/>
           </a:xfrm>
           <a:prstGeom prst="rect">
             <a:avLst/>
@@ -8366,7 +8276,7 @@
         <p:spPr>
           <a:xfrm>
             <a:off x="9685080" y="4568760"/>
-            <a:ext cx="3188880" cy="290520"/>
+            <a:ext cx="3188520" cy="290160"/>
           </a:xfrm>
           <a:prstGeom prst="rect">
             <a:avLst/>
@@ -8423,7 +8333,7 @@
         <p:spPr>
           <a:xfrm>
             <a:off x="9685080" y="4977000"/>
-            <a:ext cx="3918600" cy="898920"/>
+            <a:ext cx="3918240" cy="898560"/>
           </a:xfrm>
           <a:prstGeom prst="rect">
             <a:avLst/>
@@ -8480,7 +8390,7 @@
         <p:spPr>
           <a:xfrm>
             <a:off x="820440" y="6601320"/>
-            <a:ext cx="12988440" cy="822960"/>
+            <a:ext cx="12988080" cy="822600"/>
           </a:xfrm>
           <a:prstGeom prst="roundRect">
             <a:avLst>
@@ -8532,7 +8442,7 @@
         <p:spPr>
           <a:xfrm>
             <a:off x="1025640" y="6891480"/>
-            <a:ext cx="255600" cy="204480"/>
+            <a:ext cx="255240" cy="204120"/>
           </a:xfrm>
           <a:prstGeom prst="rect">
             <a:avLst/>
@@ -8551,7 +8461,7 @@
         <p:spPr>
           <a:xfrm>
             <a:off x="1487160" y="6847200"/>
-            <a:ext cx="12116880" cy="299160"/>
+            <a:ext cx="12116520" cy="298800"/>
           </a:xfrm>
           <a:prstGeom prst="rect">
             <a:avLst/>
@@ -8652,13 +8562,13 @@
       <p:sp>
         <p:nvSpPr>
           <p:cNvPr id="185" name=""/>
-          <p:cNvSpPr txBox="1"/>
+          <p:cNvSpPr/>
           <p:nvPr/>
         </p:nvSpPr>
         <p:spPr>
           <a:xfrm>
             <a:off x="5029200" y="84600"/>
-            <a:ext cx="3151080" cy="601200"/>
+            <a:ext cx="3150720" cy="600840"/>
           </a:xfrm>
           <a:prstGeom prst="rect">
             <a:avLst/>
@@ -8668,11 +8578,22 @@
             <a:noFill/>
           </a:ln>
         </p:spPr>
+        <p:style>
+          <a:lnRef idx="0"/>
+          <a:fillRef idx="0"/>
+          <a:effectRef idx="0"/>
+          <a:fontRef idx="minor"/>
+        </p:style>
         <p:txBody>
           <a:bodyPr lIns="90000" rIns="90000" tIns="45000" bIns="45000" anchor="t">
             <a:noAutofit/>
           </a:bodyPr>
           <a:p>
+            <a:pPr>
+              <a:lnSpc>
+                <a:spcPct val="100000"/>
+              </a:lnSpc>
+            </a:pPr>
             <a:r>
               <a:rPr b="1" lang="en-US" sz="2950" spc="-1" strike="noStrike">
                 <a:solidFill>
@@ -8705,7 +8626,7 @@
         <p:spPr>
           <a:xfrm>
             <a:off x="2971800" y="685800"/>
-            <a:ext cx="7275960" cy="7275960"/>
+            <a:ext cx="7275600" cy="7275600"/>
           </a:xfrm>
           <a:prstGeom prst="rect">
             <a:avLst/>
@@ -8754,7 +8675,7 @@
         <p:spPr>
           <a:xfrm>
             <a:off x="863640" y="1287360"/>
-            <a:ext cx="6845760" cy="612720"/>
+            <a:ext cx="6845400" cy="612360"/>
           </a:xfrm>
           <a:prstGeom prst="rect">
             <a:avLst/>
@@ -8811,7 +8732,7 @@
         <p:spPr>
           <a:xfrm>
             <a:off x="863640" y="2332800"/>
-            <a:ext cx="12902040" cy="647280"/>
+            <a:ext cx="12901680" cy="646920"/>
           </a:xfrm>
           <a:prstGeom prst="rect">
             <a:avLst/>
@@ -8888,7 +8809,7 @@
         <p:spPr>
           <a:xfrm>
             <a:off x="863640" y="3223440"/>
-            <a:ext cx="215280" cy="269280"/>
+            <a:ext cx="214920" cy="268920"/>
           </a:xfrm>
           <a:prstGeom prst="rect">
             <a:avLst/>
@@ -8945,7 +8866,7 @@
         <p:spPr>
           <a:xfrm>
             <a:off x="863640" y="3560040"/>
-            <a:ext cx="6342840" cy="29880"/>
+            <a:ext cx="6342480" cy="29520"/>
           </a:xfrm>
           <a:prstGeom prst="rect">
             <a:avLst/>
@@ -8991,7 +8912,7 @@
         <p:spPr>
           <a:xfrm>
             <a:off x="863640" y="3728880"/>
-            <a:ext cx="2453400" cy="306000"/>
+            <a:ext cx="2453040" cy="305640"/>
           </a:xfrm>
           <a:prstGeom prst="rect">
             <a:avLst/>
@@ -9048,7 +8969,7 @@
         <p:spPr>
           <a:xfrm>
             <a:off x="863640" y="4165200"/>
-            <a:ext cx="6342840" cy="647280"/>
+            <a:ext cx="6342480" cy="646920"/>
           </a:xfrm>
           <a:prstGeom prst="rect">
             <a:avLst/>
@@ -9105,7 +9026,7 @@
         <p:spPr>
           <a:xfrm>
             <a:off x="7423200" y="3223440"/>
-            <a:ext cx="215280" cy="269280"/>
+            <a:ext cx="214920" cy="268920"/>
           </a:xfrm>
           <a:prstGeom prst="rect">
             <a:avLst/>
@@ -9162,7 +9083,7 @@
         <p:spPr>
           <a:xfrm>
             <a:off x="7423200" y="3560040"/>
-            <a:ext cx="6342840" cy="29880"/>
+            <a:ext cx="6342480" cy="29520"/>
           </a:xfrm>
           <a:prstGeom prst="rect">
             <a:avLst/>
@@ -9208,7 +9129,7 @@
         <p:spPr>
           <a:xfrm>
             <a:off x="7423200" y="3728880"/>
-            <a:ext cx="4632840" cy="306000"/>
+            <a:ext cx="4632480" cy="305640"/>
           </a:xfrm>
           <a:prstGeom prst="rect">
             <a:avLst/>
@@ -9265,7 +9186,7 @@
         <p:spPr>
           <a:xfrm>
             <a:off x="7423200" y="4165200"/>
-            <a:ext cx="6342840" cy="647280"/>
+            <a:ext cx="6342480" cy="646920"/>
           </a:xfrm>
           <a:prstGeom prst="rect">
             <a:avLst/>
@@ -9322,7 +9243,7 @@
         <p:spPr>
           <a:xfrm>
             <a:off x="863640" y="5190840"/>
-            <a:ext cx="215280" cy="269280"/>
+            <a:ext cx="214920" cy="268920"/>
           </a:xfrm>
           <a:prstGeom prst="rect">
             <a:avLst/>
@@ -9379,7 +9300,7 @@
         <p:spPr>
           <a:xfrm>
             <a:off x="863640" y="5527080"/>
-            <a:ext cx="6342840" cy="29880"/>
+            <a:ext cx="6342480" cy="29520"/>
           </a:xfrm>
           <a:prstGeom prst="rect">
             <a:avLst/>
@@ -9425,7 +9346,7 @@
         <p:spPr>
           <a:xfrm>
             <a:off x="863640" y="5695920"/>
-            <a:ext cx="2453400" cy="306000"/>
+            <a:ext cx="2453040" cy="305640"/>
           </a:xfrm>
           <a:prstGeom prst="rect">
             <a:avLst/>
@@ -9482,7 +9403,7 @@
         <p:spPr>
           <a:xfrm>
             <a:off x="863640" y="6132240"/>
-            <a:ext cx="6342840" cy="647280"/>
+            <a:ext cx="6342480" cy="646920"/>
           </a:xfrm>
           <a:prstGeom prst="rect">
             <a:avLst/>
@@ -9539,7 +9460,7 @@
         <p:spPr>
           <a:xfrm>
             <a:off x="7423200" y="5190840"/>
-            <a:ext cx="215280" cy="269280"/>
+            <a:ext cx="214920" cy="268920"/>
           </a:xfrm>
           <a:prstGeom prst="rect">
             <a:avLst/>
@@ -9596,7 +9517,7 @@
         <p:spPr>
           <a:xfrm>
             <a:off x="7423200" y="5527080"/>
-            <a:ext cx="6342840" cy="29880"/>
+            <a:ext cx="6342480" cy="29520"/>
           </a:xfrm>
           <a:prstGeom prst="rect">
             <a:avLst/>
@@ -9642,7 +9563,7 @@
         <p:spPr>
           <a:xfrm>
             <a:off x="7423200" y="5695920"/>
-            <a:ext cx="2453400" cy="306000"/>
+            <a:ext cx="2453040" cy="305640"/>
           </a:xfrm>
           <a:prstGeom prst="rect">
             <a:avLst/>
@@ -9699,7 +9620,7 @@
         <p:spPr>
           <a:xfrm>
             <a:off x="7423200" y="6132240"/>
-            <a:ext cx="6342840" cy="647280"/>
+            <a:ext cx="6342480" cy="646920"/>
           </a:xfrm>
           <a:prstGeom prst="rect">
             <a:avLst/>
@@ -9790,7 +9711,7 @@
         <p:spPr>
           <a:xfrm>
             <a:off x="9144000" y="0"/>
-            <a:ext cx="5485680" cy="8228880"/>
+            <a:ext cx="5485320" cy="8228520"/>
           </a:xfrm>
           <a:prstGeom prst="rect">
             <a:avLst/>
@@ -9809,7 +9730,7 @@
         <p:spPr>
           <a:xfrm>
             <a:off x="863640" y="775440"/>
-            <a:ext cx="4907880" cy="612720"/>
+            <a:ext cx="4907520" cy="612360"/>
           </a:xfrm>
           <a:prstGeom prst="rect">
             <a:avLst/>
@@ -9866,7 +9787,7 @@
         <p:spPr>
           <a:xfrm>
             <a:off x="863640" y="1424880"/>
-            <a:ext cx="7415640" cy="1295280"/>
+            <a:ext cx="7415280" cy="1294920"/>
           </a:xfrm>
           <a:prstGeom prst="rect">
             <a:avLst/>
@@ -9933,7 +9854,7 @@
         <p:spPr>
           <a:xfrm>
             <a:off x="863640" y="3251880"/>
-            <a:ext cx="3599640" cy="2469960"/>
+            <a:ext cx="3599280" cy="2469600"/>
           </a:xfrm>
           <a:prstGeom prst="roundRect">
             <a:avLst>
@@ -9981,7 +9902,7 @@
         <p:spPr>
           <a:xfrm>
             <a:off x="1079640" y="3467520"/>
-            <a:ext cx="2453400" cy="306000"/>
+            <a:ext cx="2453040" cy="305640"/>
           </a:xfrm>
           <a:prstGeom prst="rect">
             <a:avLst/>
@@ -10058,7 +9979,7 @@
         <p:spPr>
           <a:xfrm>
             <a:off x="1079640" y="3903840"/>
-            <a:ext cx="3167640" cy="1295280"/>
+            <a:ext cx="3167280" cy="1294920"/>
           </a:xfrm>
           <a:prstGeom prst="rect">
             <a:avLst/>
@@ -10115,7 +10036,7 @@
         <p:spPr>
           <a:xfrm>
             <a:off x="4680000" y="3251880"/>
-            <a:ext cx="3599640" cy="2469960"/>
+            <a:ext cx="3599280" cy="2469600"/>
           </a:xfrm>
           <a:prstGeom prst="roundRect">
             <a:avLst>
@@ -10163,7 +10084,7 @@
         <p:spPr>
           <a:xfrm>
             <a:off x="4895640" y="3467520"/>
-            <a:ext cx="3168000" cy="612720"/>
+            <a:ext cx="3167640" cy="612360"/>
           </a:xfrm>
           <a:prstGeom prst="rect">
             <a:avLst/>
@@ -10240,7 +10161,7 @@
         <p:spPr>
           <a:xfrm>
             <a:off x="4895640" y="4210560"/>
-            <a:ext cx="3168000" cy="1295280"/>
+            <a:ext cx="3167640" cy="1294920"/>
           </a:xfrm>
           <a:prstGeom prst="rect">
             <a:avLst/>
@@ -10297,7 +10218,7 @@
         <p:spPr>
           <a:xfrm>
             <a:off x="863640" y="5938200"/>
-            <a:ext cx="7415640" cy="1515240"/>
+            <a:ext cx="7415280" cy="1514880"/>
           </a:xfrm>
           <a:prstGeom prst="roundRect">
             <a:avLst>
@@ -10345,7 +10266,7 @@
         <p:spPr>
           <a:xfrm>
             <a:off x="1079640" y="6153840"/>
-            <a:ext cx="2453400" cy="306000"/>
+            <a:ext cx="2453040" cy="305640"/>
           </a:xfrm>
           <a:prstGeom prst="rect">
             <a:avLst/>
@@ -10422,7 +10343,7 @@
         <p:spPr>
           <a:xfrm>
             <a:off x="1079640" y="6590160"/>
-            <a:ext cx="6984000" cy="647280"/>
+            <a:ext cx="6983640" cy="646920"/>
           </a:xfrm>
           <a:prstGeom prst="rect">
             <a:avLst/>
@@ -10509,7 +10430,7 @@
         <p:spPr>
           <a:xfrm>
             <a:off x="863640" y="1557000"/>
-            <a:ext cx="8353440" cy="612720"/>
+            <a:ext cx="8353080" cy="612360"/>
           </a:xfrm>
           <a:prstGeom prst="rect">
             <a:avLst/>
@@ -10566,7 +10487,7 @@
         <p:spPr>
           <a:xfrm>
             <a:off x="863640" y="2602440"/>
-            <a:ext cx="12902040" cy="647280"/>
+            <a:ext cx="12901680" cy="646920"/>
           </a:xfrm>
           <a:prstGeom prst="rect">
             <a:avLst/>
@@ -10623,7 +10544,7 @@
         <p:spPr>
           <a:xfrm>
             <a:off x="863640" y="3493080"/>
-            <a:ext cx="4156200" cy="3178800"/>
+            <a:ext cx="4155840" cy="3178440"/>
           </a:xfrm>
           <a:prstGeom prst="roundRect">
             <a:avLst>
@@ -10674,7 +10595,7 @@
         <p:spPr>
           <a:xfrm>
             <a:off x="833400" y="3493080"/>
-            <a:ext cx="121320" cy="3178800"/>
+            <a:ext cx="120960" cy="3178440"/>
           </a:xfrm>
           <a:prstGeom prst="roundRect">
             <a:avLst>
@@ -10722,7 +10643,7 @@
         <p:spPr>
           <a:xfrm>
             <a:off x="1201680" y="3703680"/>
-            <a:ext cx="3572280" cy="612720"/>
+            <a:ext cx="3571920" cy="612360"/>
           </a:xfrm>
           <a:prstGeom prst="rect">
             <a:avLst/>
@@ -10799,7 +10720,7 @@
         <p:spPr>
           <a:xfrm>
             <a:off x="1201680" y="4338360"/>
-            <a:ext cx="3572280" cy="1942920"/>
+            <a:ext cx="3571920" cy="1942560"/>
           </a:xfrm>
           <a:prstGeom prst="rect">
             <a:avLst/>
@@ -10856,7 +10777,7 @@
         <p:spPr>
           <a:xfrm>
             <a:off x="5236560" y="3493080"/>
-            <a:ext cx="4156200" cy="3178800"/>
+            <a:ext cx="4155840" cy="3178440"/>
           </a:xfrm>
           <a:prstGeom prst="roundRect">
             <a:avLst>
@@ -10907,7 +10828,7 @@
         <p:spPr>
           <a:xfrm>
             <a:off x="5205960" y="3493080"/>
-            <a:ext cx="121320" cy="3178800"/>
+            <a:ext cx="120960" cy="3178440"/>
           </a:xfrm>
           <a:prstGeom prst="roundRect">
             <a:avLst>
@@ -10955,7 +10876,7 @@
         <p:spPr>
           <a:xfrm>
             <a:off x="5574240" y="3739680"/>
-            <a:ext cx="3572280" cy="612720"/>
+            <a:ext cx="3571920" cy="612360"/>
           </a:xfrm>
           <a:prstGeom prst="rect">
             <a:avLst/>
@@ -11032,7 +10953,7 @@
         <p:spPr>
           <a:xfrm>
             <a:off x="5574240" y="4482360"/>
-            <a:ext cx="3572280" cy="1619280"/>
+            <a:ext cx="3571920" cy="1618920"/>
           </a:xfrm>
           <a:prstGeom prst="rect">
             <a:avLst/>
@@ -11089,7 +11010,7 @@
         <p:spPr>
           <a:xfrm>
             <a:off x="9609480" y="3493080"/>
-            <a:ext cx="4156200" cy="3178800"/>
+            <a:ext cx="4155840" cy="3178440"/>
           </a:xfrm>
           <a:prstGeom prst="roundRect">
             <a:avLst>
@@ -11140,7 +11061,7 @@
         <p:spPr>
           <a:xfrm>
             <a:off x="9578880" y="3493080"/>
-            <a:ext cx="121320" cy="3178800"/>
+            <a:ext cx="120960" cy="3178440"/>
           </a:xfrm>
           <a:prstGeom prst="roundRect">
             <a:avLst>
@@ -11188,7 +11109,7 @@
         <p:spPr>
           <a:xfrm>
             <a:off x="9947160" y="3739680"/>
-            <a:ext cx="3572280" cy="612720"/>
+            <a:ext cx="3571920" cy="612360"/>
           </a:xfrm>
           <a:prstGeom prst="rect">
             <a:avLst/>
@@ -11265,7 +11186,7 @@
         <p:spPr>
           <a:xfrm>
             <a:off x="9947160" y="4482360"/>
-            <a:ext cx="3572280" cy="1295280"/>
+            <a:ext cx="3571920" cy="1294920"/>
           </a:xfrm>
           <a:prstGeom prst="rect">
             <a:avLst/>
@@ -11356,7 +11277,7 @@
         <p:spPr>
           <a:xfrm>
             <a:off x="0" y="0"/>
-            <a:ext cx="5485680" cy="8228880"/>
+            <a:ext cx="5485320" cy="8228520"/>
           </a:xfrm>
           <a:prstGeom prst="rect">
             <a:avLst/>
@@ -11375,7 +11296,7 @@
         <p:spPr>
           <a:xfrm>
             <a:off x="6309720" y="783720"/>
-            <a:ext cx="7496280" cy="1168920"/>
+            <a:ext cx="7495920" cy="1168560"/>
           </a:xfrm>
           <a:prstGeom prst="rect">
             <a:avLst/>
@@ -11432,7 +11353,7 @@
         <p:spPr>
           <a:xfrm>
             <a:off x="6309720" y="2247480"/>
-            <a:ext cx="7496280" cy="1613160"/>
+            <a:ext cx="7495920" cy="1612800"/>
           </a:xfrm>
           <a:prstGeom prst="rect">
             <a:avLst/>
@@ -11489,7 +11410,7 @@
         <p:spPr>
           <a:xfrm>
             <a:off x="6309720" y="4155840"/>
-            <a:ext cx="7496280" cy="903600"/>
+            <a:ext cx="7495920" cy="903240"/>
           </a:xfrm>
           <a:prstGeom prst="rect">
             <a:avLst/>
@@ -11565,8 +11486,8 @@
         </p:nvSpPr>
         <p:spPr>
           <a:xfrm>
-            <a:off x="6161760" y="5280840"/>
-            <a:ext cx="3793320" cy="2262600"/>
+            <a:off x="6233760" y="5280840"/>
+            <a:ext cx="3792960" cy="2262240"/>
           </a:xfrm>
           <a:prstGeom prst="roundRect">
             <a:avLst>
@@ -11614,7 +11535,7 @@
         <p:spPr>
           <a:xfrm>
             <a:off x="6367320" y="5477400"/>
-            <a:ext cx="2338560" cy="291600"/>
+            <a:ext cx="2338200" cy="291240"/>
           </a:xfrm>
           <a:prstGeom prst="rect">
             <a:avLst/>
@@ -11671,7 +11592,7 @@
         <p:spPr>
           <a:xfrm>
             <a:off x="6367320" y="5965920"/>
-            <a:ext cx="3381480" cy="1410840"/>
+            <a:ext cx="3587400" cy="1410480"/>
           </a:xfrm>
           <a:prstGeom prst="rect">
             <a:avLst/>
@@ -11814,7 +11735,7 @@
         <p:spPr>
           <a:xfrm>
             <a:off x="10317240" y="5477400"/>
-            <a:ext cx="2338560" cy="291600"/>
+            <a:ext cx="2338200" cy="291240"/>
           </a:xfrm>
           <a:prstGeom prst="rect">
             <a:avLst/>
@@ -11871,7 +11792,7 @@
         <p:spPr>
           <a:xfrm>
             <a:off x="10317240" y="5965920"/>
-            <a:ext cx="3496680" cy="1410840"/>
+            <a:ext cx="3855960" cy="1410480"/>
           </a:xfrm>
           <a:prstGeom prst="rect">
             <a:avLst/>
@@ -12044,7 +11965,7 @@
         <p:spPr>
           <a:xfrm>
             <a:off x="863640" y="1641240"/>
-            <a:ext cx="6262920" cy="612720"/>
+            <a:ext cx="6262560" cy="612360"/>
           </a:xfrm>
           <a:prstGeom prst="rect">
             <a:avLst/>
@@ -12101,7 +12022,7 @@
         <p:spPr>
           <a:xfrm>
             <a:off x="863640" y="2686680"/>
-            <a:ext cx="12902040" cy="647280"/>
+            <a:ext cx="12901680" cy="646920"/>
           </a:xfrm>
           <a:prstGeom prst="rect">
             <a:avLst/>
@@ -12162,7 +12083,7 @@
         <p:spPr>
           <a:xfrm>
             <a:off x="863640" y="3577320"/>
-            <a:ext cx="905760" cy="905760"/>
+            <a:ext cx="905400" cy="905400"/>
           </a:xfrm>
           <a:prstGeom prst="rect">
             <a:avLst/>
@@ -12181,7 +12102,7 @@
         <p:spPr>
           <a:xfrm>
             <a:off x="2040120" y="3577320"/>
-            <a:ext cx="2943720" cy="612720"/>
+            <a:ext cx="2943360" cy="612360"/>
           </a:xfrm>
           <a:prstGeom prst="rect">
             <a:avLst/>
@@ -12238,7 +12159,7 @@
         <p:spPr>
           <a:xfrm>
             <a:off x="2040120" y="4320360"/>
-            <a:ext cx="2943720" cy="2266920"/>
+            <a:ext cx="2943360" cy="2266560"/>
           </a:xfrm>
           <a:prstGeom prst="rect">
             <a:avLst/>
@@ -12329,7 +12250,7 @@
         <p:spPr>
           <a:xfrm>
             <a:off x="5254560" y="3577320"/>
-            <a:ext cx="905760" cy="905760"/>
+            <a:ext cx="905400" cy="905400"/>
           </a:xfrm>
           <a:prstGeom prst="rect">
             <a:avLst/>
@@ -12348,7 +12269,7 @@
         <p:spPr>
           <a:xfrm>
             <a:off x="6431040" y="3577320"/>
-            <a:ext cx="2943720" cy="612720"/>
+            <a:ext cx="2943360" cy="612360"/>
           </a:xfrm>
           <a:prstGeom prst="rect">
             <a:avLst/>
@@ -12405,7 +12326,7 @@
         <p:spPr>
           <a:xfrm>
             <a:off x="6431040" y="4320360"/>
-            <a:ext cx="2943720" cy="1942920"/>
+            <a:ext cx="2943360" cy="1942560"/>
           </a:xfrm>
           <a:prstGeom prst="rect">
             <a:avLst/>
@@ -12466,7 +12387,7 @@
         <p:spPr>
           <a:xfrm>
             <a:off x="9645480" y="3577320"/>
-            <a:ext cx="905760" cy="905760"/>
+            <a:ext cx="905400" cy="905400"/>
           </a:xfrm>
           <a:prstGeom prst="rect">
             <a:avLst/>
@@ -12485,7 +12406,7 @@
         <p:spPr>
           <a:xfrm>
             <a:off x="10821960" y="3577320"/>
-            <a:ext cx="2943720" cy="612720"/>
+            <a:ext cx="2943360" cy="612360"/>
           </a:xfrm>
           <a:prstGeom prst="rect">
             <a:avLst/>
@@ -12542,7 +12463,7 @@
         <p:spPr>
           <a:xfrm>
             <a:off x="10821960" y="4320360"/>
-            <a:ext cx="2943720" cy="1942920"/>
+            <a:ext cx="2943360" cy="1942560"/>
           </a:xfrm>
           <a:prstGeom prst="rect">
             <a:avLst/>
@@ -12629,7 +12550,7 @@
         <p:spPr>
           <a:xfrm>
             <a:off x="863640" y="1684440"/>
-            <a:ext cx="6903000" cy="612720"/>
+            <a:ext cx="6902640" cy="612360"/>
           </a:xfrm>
           <a:prstGeom prst="rect">
             <a:avLst/>
@@ -12686,7 +12607,7 @@
         <p:spPr>
           <a:xfrm>
             <a:off x="431640" y="2621880"/>
-            <a:ext cx="12902040" cy="323280"/>
+            <a:ext cx="12901680" cy="322920"/>
           </a:xfrm>
           <a:prstGeom prst="rect">
             <a:avLst/>
@@ -12753,7 +12674,7 @@
         <p:spPr>
           <a:xfrm>
             <a:off x="863640" y="3296880"/>
-            <a:ext cx="539280" cy="539280"/>
+            <a:ext cx="538920" cy="538920"/>
           </a:xfrm>
           <a:prstGeom prst="rect">
             <a:avLst/>
@@ -12772,7 +12693,7 @@
         <p:spPr>
           <a:xfrm>
             <a:off x="1673640" y="3296880"/>
-            <a:ext cx="3909600" cy="306000"/>
+            <a:ext cx="3909240" cy="305640"/>
           </a:xfrm>
           <a:prstGeom prst="rect">
             <a:avLst/>
@@ -12829,7 +12750,7 @@
         <p:spPr>
           <a:xfrm>
             <a:off x="1673640" y="3733200"/>
-            <a:ext cx="5505840" cy="971280"/>
+            <a:ext cx="5505480" cy="970920"/>
           </a:xfrm>
           <a:prstGeom prst="rect">
             <a:avLst/>
@@ -12896,7 +12817,7 @@
         <p:spPr>
           <a:xfrm>
             <a:off x="7450200" y="3296880"/>
-            <a:ext cx="539280" cy="539280"/>
+            <a:ext cx="538920" cy="538920"/>
           </a:xfrm>
           <a:prstGeom prst="rect">
             <a:avLst/>
@@ -12915,7 +12836,7 @@
         <p:spPr>
           <a:xfrm>
             <a:off x="8259840" y="3296880"/>
-            <a:ext cx="3069000" cy="306000"/>
+            <a:ext cx="3068640" cy="305640"/>
           </a:xfrm>
           <a:prstGeom prst="rect">
             <a:avLst/>
@@ -12972,7 +12893,7 @@
         <p:spPr>
           <a:xfrm>
             <a:off x="8259840" y="3733200"/>
-            <a:ext cx="5506200" cy="971280"/>
+            <a:ext cx="5505840" cy="970920"/>
           </a:xfrm>
           <a:prstGeom prst="rect">
             <a:avLst/>
@@ -13039,7 +12960,7 @@
         <p:spPr>
           <a:xfrm>
             <a:off x="863640" y="5136840"/>
-            <a:ext cx="539280" cy="539280"/>
+            <a:ext cx="538920" cy="538920"/>
           </a:xfrm>
           <a:prstGeom prst="rect">
             <a:avLst/>
@@ -13058,7 +12979,7 @@
         <p:spPr>
           <a:xfrm>
             <a:off x="1673640" y="5136840"/>
-            <a:ext cx="3441960" cy="306000"/>
+            <a:ext cx="3441600" cy="305640"/>
           </a:xfrm>
           <a:prstGeom prst="rect">
             <a:avLst/>
@@ -13115,7 +13036,7 @@
         <p:spPr>
           <a:xfrm>
             <a:off x="1673640" y="5573160"/>
-            <a:ext cx="5505840" cy="971280"/>
+            <a:ext cx="5505480" cy="970920"/>
           </a:xfrm>
           <a:prstGeom prst="rect">
             <a:avLst/>
@@ -13182,7 +13103,7 @@
         <p:spPr>
           <a:xfrm>
             <a:off x="7450200" y="5136840"/>
-            <a:ext cx="539280" cy="539280"/>
+            <a:ext cx="538920" cy="538920"/>
           </a:xfrm>
           <a:prstGeom prst="rect">
             <a:avLst/>
@@ -13201,7 +13122,7 @@
         <p:spPr>
           <a:xfrm>
             <a:off x="8259840" y="5136840"/>
-            <a:ext cx="3048840" cy="306000"/>
+            <a:ext cx="3048480" cy="305640"/>
           </a:xfrm>
           <a:prstGeom prst="rect">
             <a:avLst/>
@@ -13258,7 +13179,7 @@
         <p:spPr>
           <a:xfrm>
             <a:off x="8259840" y="5573160"/>
-            <a:ext cx="5506200" cy="971280"/>
+            <a:ext cx="5505840" cy="970920"/>
           </a:xfrm>
           <a:prstGeom prst="rect">
             <a:avLst/>
@@ -13345,7 +13266,7 @@
         <p:spPr>
           <a:xfrm>
             <a:off x="783360" y="538560"/>
-            <a:ext cx="5399640" cy="555480"/>
+            <a:ext cx="5399280" cy="555120"/>
           </a:xfrm>
           <a:prstGeom prst="rect">
             <a:avLst/>
@@ -13402,7 +13323,7 @@
         <p:spPr>
           <a:xfrm>
             <a:off x="783360" y="1449720"/>
-            <a:ext cx="13063320" cy="559440"/>
+            <a:ext cx="13062960" cy="559080"/>
           </a:xfrm>
           <a:prstGeom prst="rect">
             <a:avLst/>
@@ -13463,7 +13384,7 @@
         <p:spPr>
           <a:xfrm>
             <a:off x="992520" y="2209320"/>
-            <a:ext cx="12644640" cy="4744440"/>
+            <a:ext cx="12644280" cy="4744080"/>
           </a:xfrm>
           <a:prstGeom prst="rect">
             <a:avLst/>
@@ -13492,7 +13413,7 @@
         <p:spPr>
           <a:xfrm>
             <a:off x="11791800" y="3418200"/>
-            <a:ext cx="652320" cy="652320"/>
+            <a:ext cx="651960" cy="651960"/>
           </a:xfrm>
           <a:prstGeom prst="rect">
             <a:avLst/>
@@ -13511,7 +13432,7 @@
         <p:spPr>
           <a:xfrm>
             <a:off x="11209680" y="5652360"/>
-            <a:ext cx="1906560" cy="667080"/>
+            <a:ext cx="1906200" cy="666720"/>
           </a:xfrm>
           <a:prstGeom prst="rect">
             <a:avLst/>
@@ -13548,7 +13469,7 @@
                 <a:latin typeface="Montserrat Bold"/>
                 <a:ea typeface="Montserrat Bold"/>
               </a:rPr>
-              <a:t>%90 Altı: İncele</a:t>
+              <a:t>90%-dən aşağı: İcmal</a:t>
             </a:r>
             <a:endParaRPr b="0" lang="en-US" sz="2100" spc="-1" strike="noStrike">
               <a:solidFill>
@@ -13578,7 +13499,7 @@
         <p:spPr>
           <a:xfrm>
             <a:off x="9400320" y="3419280"/>
-            <a:ext cx="652320" cy="652320"/>
+            <a:ext cx="651960" cy="651960"/>
           </a:xfrm>
           <a:prstGeom prst="rect">
             <a:avLst/>
@@ -13597,7 +13518,7 @@
         <p:spPr>
           <a:xfrm>
             <a:off x="8805960" y="5652360"/>
-            <a:ext cx="1906560" cy="667080"/>
+            <a:ext cx="1906200" cy="666720"/>
           </a:xfrm>
           <a:prstGeom prst="rect">
             <a:avLst/>
@@ -13634,7 +13555,7 @@
                 <a:latin typeface="Montserrat Bold"/>
                 <a:ea typeface="Montserrat Bold"/>
               </a:rPr>
-              <a:t>%90 Üzeri: Otomatik</a:t>
+              <a:t>90%-dən çox: Avtomatik</a:t>
             </a:r>
             <a:endParaRPr b="0" lang="en-US" sz="2100" spc="-1" strike="noStrike">
               <a:solidFill>
@@ -13664,7 +13585,7 @@
         <p:spPr>
           <a:xfrm>
             <a:off x="7009920" y="3419280"/>
-            <a:ext cx="652320" cy="652320"/>
+            <a:ext cx="651960" cy="651960"/>
           </a:xfrm>
           <a:prstGeom prst="rect">
             <a:avLst/>
@@ -13683,7 +13604,7 @@
         <p:spPr>
           <a:xfrm>
             <a:off x="6415560" y="5652360"/>
-            <a:ext cx="1906560" cy="667080"/>
+            <a:ext cx="1906200" cy="666720"/>
           </a:xfrm>
           <a:prstGeom prst="rect">
             <a:avLst/>
@@ -13720,7 +13641,7 @@
                 <a:latin typeface="Montserrat Bold"/>
                 <a:ea typeface="Montserrat Bold"/>
               </a:rPr>
-              <a:t>Model Güven Skoru</a:t>
+              <a:t>Modelin Etibarlılıq İndikatoru</a:t>
             </a:r>
             <a:endParaRPr b="0" lang="en-US" sz="2100" spc="-1" strike="noStrike">
               <a:solidFill>
@@ -13750,7 +13671,7 @@
         <p:spPr>
           <a:xfrm>
             <a:off x="4619160" y="3419280"/>
-            <a:ext cx="652320" cy="652320"/>
+            <a:ext cx="651960" cy="651960"/>
           </a:xfrm>
           <a:prstGeom prst="rect">
             <a:avLst/>
@@ -13769,7 +13690,7 @@
         <p:spPr>
           <a:xfrm>
             <a:off x="4024800" y="5652360"/>
-            <a:ext cx="1906560" cy="667080"/>
+            <a:ext cx="1906200" cy="666720"/>
           </a:xfrm>
           <a:prstGeom prst="rect">
             <a:avLst/>
@@ -13806,7 +13727,7 @@
                 <a:latin typeface="Montserrat Bold"/>
                 <a:ea typeface="Montserrat Bold"/>
               </a:rPr>
-              <a:t>NLP Sınıflama</a:t>
+              <a:t>NLP Təsnifatı</a:t>
             </a:r>
             <a:endParaRPr b="0" lang="en-US" sz="2100" spc="-1" strike="noStrike">
               <a:solidFill>
@@ -13836,7 +13757,7 @@
         <p:spPr>
           <a:xfrm>
             <a:off x="2215440" y="3419280"/>
-            <a:ext cx="652320" cy="652320"/>
+            <a:ext cx="651960" cy="651960"/>
           </a:xfrm>
           <a:prstGeom prst="rect">
             <a:avLst/>
@@ -13855,7 +13776,7 @@
         <p:spPr>
           <a:xfrm>
             <a:off x="1581840" y="5652360"/>
-            <a:ext cx="1906560" cy="667080"/>
+            <a:ext cx="1906200" cy="666720"/>
           </a:xfrm>
           <a:prstGeom prst="rect">
             <a:avLst/>
@@ -13892,7 +13813,7 @@
                 <a:latin typeface="Montserrat Bold"/>
                 <a:ea typeface="Montserrat Bold"/>
               </a:rPr>
-              <a:t>E‑posta Okuma</a:t>
+              <a:t>E‑poçtanı Oxumaq</a:t>
             </a:r>
             <a:endParaRPr b="0" lang="en-US" sz="2100" spc="-1" strike="noStrike">
               <a:solidFill>
@@ -13912,7 +13833,7 @@
         <p:spPr>
           <a:xfrm>
             <a:off x="783360" y="7154280"/>
-            <a:ext cx="13063320" cy="559440"/>
+            <a:ext cx="13062960" cy="559080"/>
           </a:xfrm>
           <a:prstGeom prst="rect">
             <a:avLst/>
@@ -14038,8 +13959,8 @@
         </p:nvSpPr>
         <p:spPr>
           <a:xfrm>
-            <a:off x="863640" y="923040"/>
-            <a:ext cx="5699520" cy="612720"/>
+            <a:off x="701640" y="1143000"/>
+            <a:ext cx="5699160" cy="612360"/>
           </a:xfrm>
           <a:prstGeom prst="rect">
             <a:avLst/>
@@ -14064,6 +13985,12 @@
               <a:lnSpc>
                 <a:spcPts val="4799"/>
               </a:lnSpc>
+              <a:spcBef>
+                <a:spcPts val="1191"/>
+              </a:spcBef>
+              <a:spcAft>
+                <a:spcPts val="992"/>
+              </a:spcAft>
               <a:tabLst>
                 <a:tab algn="l" pos="0"/>
               </a:tabLst>
@@ -14076,7 +14003,28 @@
                 <a:latin typeface="Montserrat Bold"/>
                 <a:ea typeface="Montserrat Bold"/>
               </a:rPr>
-              <a:t>ROI Qiymətləndirməsi</a:t>
+              <a:t>ROI (</a:t>
+            </a:r>
+            <a:r>
+              <a:rPr b="1" lang="en-US" sz="3850" spc="-1" strike="noStrike">
+                <a:solidFill>
+                  <a:srgbClr val="ffffff"/>
+                </a:solidFill>
+                <a:latin typeface="Montserrat Bold"/>
+                <a:ea typeface="Montserrat Bold"/>
+                <a:hlinkClick r:id="rId1"/>
+              </a:rPr>
+              <a:t>Return on Investment</a:t>
+            </a:r>
+            <a:r>
+              <a:rPr b="1" lang="en-US" sz="3850" spc="-1" strike="noStrike">
+                <a:solidFill>
+                  <a:srgbClr val="ffffff"/>
+                </a:solidFill>
+                <a:latin typeface="Montserrat Bold"/>
+                <a:ea typeface="Montserrat Bold"/>
+              </a:rPr>
+              <a:t>) Qiymətləndirməsi</a:t>
             </a:r>
             <a:endParaRPr b="0" lang="en-US" sz="3850" spc="-1" strike="noStrike">
               <a:solidFill>
@@ -14096,7 +14044,7 @@
         <p:spPr>
           <a:xfrm>
             <a:off x="863640" y="1968480"/>
-            <a:ext cx="12902040" cy="647280"/>
+            <a:ext cx="12901680" cy="646920"/>
           </a:xfrm>
           <a:prstGeom prst="rect">
             <a:avLst/>
@@ -14153,7 +14101,7 @@
         <p:spPr>
           <a:xfrm>
             <a:off x="708120" y="2859480"/>
-            <a:ext cx="6498360" cy="2983320"/>
+            <a:ext cx="6498000" cy="2982960"/>
           </a:xfrm>
           <a:prstGeom prst="roundRect">
             <a:avLst>
@@ -14201,7 +14149,7 @@
         <p:spPr>
           <a:xfrm>
             <a:off x="924120" y="3075120"/>
-            <a:ext cx="2965680" cy="306000"/>
+            <a:ext cx="2965320" cy="305640"/>
           </a:xfrm>
           <a:prstGeom prst="rect">
             <a:avLst/>
@@ -14278,7 +14226,7 @@
         <p:spPr>
           <a:xfrm>
             <a:off x="924120" y="3597840"/>
-            <a:ext cx="6066720" cy="2169720"/>
+            <a:ext cx="6066360" cy="2169360"/>
           </a:xfrm>
           <a:prstGeom prst="rect">
             <a:avLst/>
@@ -14453,7 +14401,7 @@
         <p:spPr>
           <a:xfrm>
             <a:off x="7586280" y="3075120"/>
-            <a:ext cx="3312360" cy="306000"/>
+            <a:ext cx="3312000" cy="305640"/>
           </a:xfrm>
           <a:prstGeom prst="rect">
             <a:avLst/>
@@ -14530,7 +14478,7 @@
         <p:spPr>
           <a:xfrm>
             <a:off x="7586280" y="3597840"/>
-            <a:ext cx="6187320" cy="2169720"/>
+            <a:ext cx="6186960" cy="2169360"/>
           </a:xfrm>
           <a:prstGeom prst="rect">
             <a:avLst/>
@@ -14705,7 +14653,7 @@
         <p:spPr>
           <a:xfrm>
             <a:off x="863640" y="6086520"/>
-            <a:ext cx="12902040" cy="1219320"/>
+            <a:ext cx="12901680" cy="1218960"/>
           </a:xfrm>
           <a:prstGeom prst="roundRect">
             <a:avLst>
@@ -14751,13 +14699,13 @@
           <p:nvPr/>
         </p:nvPicPr>
         <p:blipFill>
-          <a:blip r:embed="rId1"/>
+          <a:blip r:embed="rId2"/>
           <a:stretch/>
         </p:blipFill>
         <p:spPr>
           <a:xfrm>
             <a:off x="1079640" y="6395760"/>
-            <a:ext cx="269280" cy="215280"/>
+            <a:ext cx="268920" cy="214920"/>
           </a:xfrm>
           <a:prstGeom prst="rect">
             <a:avLst/>
@@ -14776,7 +14724,7 @@
         <p:spPr>
           <a:xfrm>
             <a:off x="1565280" y="6356160"/>
-            <a:ext cx="11984760" cy="647280"/>
+            <a:ext cx="11984400" cy="646920"/>
           </a:xfrm>
           <a:prstGeom prst="rect">
             <a:avLst/>

</xml_diff>